<commit_message>
Added updated numbers of indirect citations analysis to text and plots. Several numbers are still pending to be added. Added figure descriptions to most plots. Rendered index.
</commit_message>
<xml_diff>
--- a/plots_files/plots_png/pptx/plots_png.pptx
+++ b/plots_files/plots_png/pptx/plots_png.pptx
@@ -255,7 +255,7 @@
           <a:p>
             <a:fld id="{83D14EEA-DE26-4810-8E05-A65F0010FADE}" type="datetimeFigureOut">
               <a:rPr lang="de-DE" smtClean="0"/>
-              <a:t>19.12.2025</a:t>
+              <a:t>04.02.2026</a:t>
             </a:fld>
             <a:endParaRPr lang="de-DE"/>
           </a:p>
@@ -425,7 +425,7 @@
           <a:p>
             <a:fld id="{83D14EEA-DE26-4810-8E05-A65F0010FADE}" type="datetimeFigureOut">
               <a:rPr lang="de-DE" smtClean="0"/>
-              <a:t>19.12.2025</a:t>
+              <a:t>04.02.2026</a:t>
             </a:fld>
             <a:endParaRPr lang="de-DE"/>
           </a:p>
@@ -605,7 +605,7 @@
           <a:p>
             <a:fld id="{83D14EEA-DE26-4810-8E05-A65F0010FADE}" type="datetimeFigureOut">
               <a:rPr lang="de-DE" smtClean="0"/>
-              <a:t>19.12.2025</a:t>
+              <a:t>04.02.2026</a:t>
             </a:fld>
             <a:endParaRPr lang="de-DE"/>
           </a:p>
@@ -775,7 +775,7 @@
           <a:p>
             <a:fld id="{83D14EEA-DE26-4810-8E05-A65F0010FADE}" type="datetimeFigureOut">
               <a:rPr lang="de-DE" smtClean="0"/>
-              <a:t>19.12.2025</a:t>
+              <a:t>04.02.2026</a:t>
             </a:fld>
             <a:endParaRPr lang="de-DE"/>
           </a:p>
@@ -1019,7 +1019,7 @@
           <a:p>
             <a:fld id="{83D14EEA-DE26-4810-8E05-A65F0010FADE}" type="datetimeFigureOut">
               <a:rPr lang="de-DE" smtClean="0"/>
-              <a:t>19.12.2025</a:t>
+              <a:t>04.02.2026</a:t>
             </a:fld>
             <a:endParaRPr lang="de-DE"/>
           </a:p>
@@ -1251,7 +1251,7 @@
           <a:p>
             <a:fld id="{83D14EEA-DE26-4810-8E05-A65F0010FADE}" type="datetimeFigureOut">
               <a:rPr lang="de-DE" smtClean="0"/>
-              <a:t>19.12.2025</a:t>
+              <a:t>04.02.2026</a:t>
             </a:fld>
             <a:endParaRPr lang="de-DE"/>
           </a:p>
@@ -1618,7 +1618,7 @@
           <a:p>
             <a:fld id="{83D14EEA-DE26-4810-8E05-A65F0010FADE}" type="datetimeFigureOut">
               <a:rPr lang="de-DE" smtClean="0"/>
-              <a:t>19.12.2025</a:t>
+              <a:t>04.02.2026</a:t>
             </a:fld>
             <a:endParaRPr lang="de-DE"/>
           </a:p>
@@ -1736,7 +1736,7 @@
           <a:p>
             <a:fld id="{83D14EEA-DE26-4810-8E05-A65F0010FADE}" type="datetimeFigureOut">
               <a:rPr lang="de-DE" smtClean="0"/>
-              <a:t>19.12.2025</a:t>
+              <a:t>04.02.2026</a:t>
             </a:fld>
             <a:endParaRPr lang="de-DE"/>
           </a:p>
@@ -1831,7 +1831,7 @@
           <a:p>
             <a:fld id="{83D14EEA-DE26-4810-8E05-A65F0010FADE}" type="datetimeFigureOut">
               <a:rPr lang="de-DE" smtClean="0"/>
-              <a:t>19.12.2025</a:t>
+              <a:t>04.02.2026</a:t>
             </a:fld>
             <a:endParaRPr lang="de-DE"/>
           </a:p>
@@ -2108,7 +2108,7 @@
           <a:p>
             <a:fld id="{83D14EEA-DE26-4810-8E05-A65F0010FADE}" type="datetimeFigureOut">
               <a:rPr lang="de-DE" smtClean="0"/>
-              <a:t>19.12.2025</a:t>
+              <a:t>04.02.2026</a:t>
             </a:fld>
             <a:endParaRPr lang="de-DE"/>
           </a:p>
@@ -2365,7 +2365,7 @@
           <a:p>
             <a:fld id="{83D14EEA-DE26-4810-8E05-A65F0010FADE}" type="datetimeFigureOut">
               <a:rPr lang="de-DE" smtClean="0"/>
-              <a:t>19.12.2025</a:t>
+              <a:t>04.02.2026</a:t>
             </a:fld>
             <a:endParaRPr lang="de-DE"/>
           </a:p>
@@ -2578,7 +2578,7 @@
           <a:p>
             <a:fld id="{83D14EEA-DE26-4810-8E05-A65F0010FADE}" type="datetimeFigureOut">
               <a:rPr lang="de-DE" smtClean="0"/>
-              <a:t>19.12.2025</a:t>
+              <a:t>04.02.2026</a:t>
             </a:fld>
             <a:endParaRPr lang="de-DE"/>
           </a:p>
@@ -5255,7 +5255,7 @@
                 <a:latin typeface="Arial" panose="020B0604020202020204" pitchFamily="34" charset="0"/>
                 <a:cs typeface="Arial" panose="020B0604020202020204" pitchFamily="34" charset="0"/>
               </a:rPr>
-              <a:t>(1,722 Citations Overall)</a:t>
+              <a:t>(1,728 Citations Overall)</a:t>
             </a:r>
           </a:p>
         </p:txBody>

</xml_diff>

<commit_message>
Changed "mentions" in fig-caps to "references"; Made sure fig-caps are up to date; Made sure that every title of figure is with caps; Fixed Fig-caps indent in supp-fig; Deleted the not-used plots-pdf.qmd; Changed "mentions" in all of the plots themselves to "References"; Rendered pdf.
</commit_message>
<xml_diff>
--- a/plots_files/plots_png/pptx/plots_png.pptx
+++ b/plots_files/plots_png/pptx/plots_png.pptx
@@ -6,7 +6,6 @@
   </p:sldMasterIdLst>
   <p:sldIdLst>
     <p:sldId id="260" r:id="rId2"/>
-    <p:sldId id="256" r:id="rId3"/>
   </p:sldIdLst>
   <p:sldSz cx="6400800" cy="9144000"/>
   <p:notesSz cx="6858000" cy="9144000"/>
@@ -3440,7 +3439,7 @@
           <p:spPr>
             <a:xfrm>
               <a:off x="5063715" y="5042445"/>
-              <a:ext cx="994363" cy="489621"/>
+              <a:ext cx="1178620" cy="489621"/>
             </a:xfrm>
             <a:prstGeom prst="rect">
               <a:avLst/>
@@ -3457,7 +3456,7 @@
                   <a:latin typeface="Arial" panose="020B0604020202020204" pitchFamily="34" charset="0"/>
                   <a:cs typeface="Arial" panose="020B0604020202020204" pitchFamily="34" charset="0"/>
                 </a:rPr>
-                <a:t>Mentioned</a:t>
+                <a:t>Referenced</a:t>
               </a:r>
             </a:p>
             <a:p>
@@ -3503,7 +3502,7 @@
                   <a:latin typeface="Arial" panose="020B0604020202020204" pitchFamily="34" charset="0"/>
                   <a:cs typeface="Arial" panose="020B0604020202020204" pitchFamily="34" charset="0"/>
                 </a:rPr>
-                <a:t>Mentions</a:t>
+                <a:t>References</a:t>
               </a:r>
             </a:p>
             <a:p>
@@ -3922,7 +3921,7 @@
                   <a:latin typeface="Arial" panose="020B0604020202020204" pitchFamily="34" charset="0"/>
                   <a:cs typeface="Arial" panose="020B0604020202020204" pitchFamily="34" charset="0"/>
                 </a:rPr>
-                <a:t>Mentioned</a:t>
+                <a:t>Referenced</a:t>
               </a:r>
             </a:p>
             <a:p>
@@ -3970,7 +3969,7 @@
                   <a:latin typeface="Arial" panose="020B0604020202020204" pitchFamily="34" charset="0"/>
                   <a:cs typeface="Arial" panose="020B0604020202020204" pitchFamily="34" charset="0"/>
                 </a:rPr>
-                <a:t>Mentions</a:t>
+                <a:t>References</a:t>
               </a:r>
             </a:p>
             <a:p>
@@ -4074,7 +4073,7 @@
                   <a:latin typeface="Arial" panose="020B0604020202020204" pitchFamily="34" charset="0"/>
                   <a:cs typeface="Arial" panose="020B0604020202020204" pitchFamily="34" charset="0"/>
                 </a:rPr>
-                <a:t>Mentions of Datasets</a:t>
+                <a:t>References of Datasets</a:t>
               </a:r>
             </a:p>
             <a:p>
@@ -4388,7 +4387,7 @@
                   <a:latin typeface="Arial" panose="020B0604020202020204" pitchFamily="34" charset="0"/>
                   <a:cs typeface="Arial" panose="020B0604020202020204" pitchFamily="34" charset="0"/>
                 </a:rPr>
-                <a:t>Mentioned Datasets</a:t>
+                <a:t>Referenced Datasets</a:t>
               </a:r>
               <a:endParaRPr lang="de-DE" sz="1291" dirty="0">
                 <a:latin typeface="Arial" panose="020B0604020202020204" pitchFamily="34" charset="0"/>
@@ -5204,710 +5203,6 @@
     <p:extLst>
       <p:ext uri="{BB962C8B-B14F-4D97-AF65-F5344CB8AC3E}">
         <p14:creationId xmlns:p14="http://schemas.microsoft.com/office/powerpoint/2010/main" val="3660736135"/>
-      </p:ext>
-    </p:extLst>
-  </p:cSld>
-  <p:clrMapOvr>
-    <a:masterClrMapping/>
-  </p:clrMapOvr>
-</p:sld>
-</file>
-
-<file path=ppt/slides/slide2.xml><?xml version="1.0" encoding="utf-8"?>
-<p:sld xmlns:a="http://schemas.openxmlformats.org/drawingml/2006/main" xmlns:r="http://schemas.openxmlformats.org/officeDocument/2006/relationships" xmlns:p="http://schemas.openxmlformats.org/presentationml/2006/main">
-  <p:cSld>
-    <p:spTree>
-      <p:nvGrpSpPr>
-        <p:cNvPr id="1" name=""/>
-        <p:cNvGrpSpPr/>
-        <p:nvPr/>
-      </p:nvGrpSpPr>
-      <p:grpSpPr>
-        <a:xfrm>
-          <a:off x="0" y="0"/>
-          <a:ext cx="0" cy="0"/>
-          <a:chOff x="0" y="0"/>
-          <a:chExt cx="0" cy="0"/>
-        </a:xfrm>
-      </p:grpSpPr>
-      <p:sp>
-        <p:nvSpPr>
-          <p:cNvPr id="3" name="Rectangle 2">
-            <a:extLst>
-              <a:ext uri="{FF2B5EF4-FFF2-40B4-BE49-F238E27FC236}">
-                <a16:creationId xmlns:a16="http://schemas.microsoft.com/office/drawing/2014/main" id="{FE9FF791-EB9E-4172-8E36-126A1971CBBF}"/>
-              </a:ext>
-            </a:extLst>
-          </p:cNvPr>
-          <p:cNvSpPr/>
-          <p:nvPr/>
-        </p:nvSpPr>
-        <p:spPr>
-          <a:xfrm>
-            <a:off x="4236419" y="1775732"/>
-            <a:ext cx="2655710" cy="480581"/>
-          </a:xfrm>
-          <a:prstGeom prst="rect">
-            <a:avLst/>
-          </a:prstGeom>
-        </p:spPr>
-        <p:txBody>
-          <a:bodyPr wrap="square">
-            <a:spAutoFit/>
-          </a:bodyPr>
-          <a:lstStyle/>
-          <a:p>
-            <a:r>
-              <a:rPr lang="en-US" sz="1291" dirty="0">
-                <a:latin typeface="Arial" panose="020B0604020202020204" pitchFamily="34" charset="0"/>
-                <a:cs typeface="Arial" panose="020B0604020202020204" pitchFamily="34" charset="0"/>
-              </a:rPr>
-              <a:t>Confirmed Indirect Data Citations</a:t>
-            </a:r>
-          </a:p>
-          <a:p>
-            <a:r>
-              <a:rPr lang="de-DE" sz="1232" dirty="0">
-                <a:solidFill>
-                  <a:schemeClr val="bg1">
-                    <a:lumMod val="50000"/>
-                  </a:schemeClr>
-                </a:solidFill>
-                <a:latin typeface="Arial" panose="020B0604020202020204" pitchFamily="34" charset="0"/>
-                <a:cs typeface="Arial" panose="020B0604020202020204" pitchFamily="34" charset="0"/>
-              </a:rPr>
-              <a:t>(1,728 Citations Overall)</a:t>
-            </a:r>
-          </a:p>
-        </p:txBody>
-      </p:sp>
-      <p:sp>
-        <p:nvSpPr>
-          <p:cNvPr id="32" name="Rectangle: Rounded Corners 31">
-            <a:extLst>
-              <a:ext uri="{FF2B5EF4-FFF2-40B4-BE49-F238E27FC236}">
-                <a16:creationId xmlns:a16="http://schemas.microsoft.com/office/drawing/2014/main" id="{759DB630-BAD7-4C3C-8ABD-E809EE7D6421}"/>
-              </a:ext>
-            </a:extLst>
-          </p:cNvPr>
-          <p:cNvSpPr/>
-          <p:nvPr/>
-        </p:nvSpPr>
-        <p:spPr>
-          <a:xfrm>
-            <a:off x="3242037" y="1806988"/>
-            <a:ext cx="994383" cy="412615"/>
-          </a:xfrm>
-          <a:prstGeom prst="roundRect">
-            <a:avLst/>
-          </a:prstGeom>
-          <a:gradFill flip="none" rotWithShape="1">
-            <a:gsLst>
-              <a:gs pos="84000">
-                <a:srgbClr val="75D4FF"/>
-              </a:gs>
-              <a:gs pos="68000">
-                <a:srgbClr val="00B0F0"/>
-              </a:gs>
-              <a:gs pos="100000">
-                <a:schemeClr val="bg1">
-                  <a:lumMod val="95000"/>
-                </a:schemeClr>
-              </a:gs>
-            </a:gsLst>
-            <a:lin ang="18900000" scaled="1"/>
-            <a:tileRect/>
-          </a:gradFill>
-          <a:ln>
-            <a:noFill/>
-          </a:ln>
-          <a:effectLst>
-            <a:outerShdw blurRad="50800" dist="38100" dir="8100000" algn="tr" rotWithShape="0">
-              <a:prstClr val="black">
-                <a:alpha val="40000"/>
-              </a:prstClr>
-            </a:outerShdw>
-          </a:effectLst>
-        </p:spPr>
-        <p:style>
-          <a:lnRef idx="2">
-            <a:schemeClr val="accent1">
-              <a:shade val="50000"/>
-            </a:schemeClr>
-          </a:lnRef>
-          <a:fillRef idx="1">
-            <a:schemeClr val="accent1"/>
-          </a:fillRef>
-          <a:effectRef idx="0">
-            <a:schemeClr val="accent1"/>
-          </a:effectRef>
-          <a:fontRef idx="minor">
-            <a:schemeClr val="lt1"/>
-          </a:fontRef>
-        </p:style>
-        <p:txBody>
-          <a:bodyPr rtlCol="0" anchor="ctr"/>
-          <a:lstStyle/>
-          <a:p>
-            <a:pPr algn="ctr"/>
-            <a:r>
-              <a:rPr lang="en-US" sz="1408" dirty="0">
-                <a:solidFill>
-                  <a:schemeClr val="tx1"/>
-                </a:solidFill>
-                <a:latin typeface="Arial" panose="020B0604020202020204" pitchFamily="34" charset="0"/>
-                <a:cs typeface="Arial" panose="020B0604020202020204" pitchFamily="34" charset="0"/>
-              </a:rPr>
-              <a:t>113</a:t>
-            </a:r>
-            <a:endParaRPr lang="de-DE" sz="1408" dirty="0">
-              <a:solidFill>
-                <a:schemeClr val="tx1"/>
-              </a:solidFill>
-              <a:latin typeface="Arial" panose="020B0604020202020204" pitchFamily="34" charset="0"/>
-              <a:cs typeface="Arial" panose="020B0604020202020204" pitchFamily="34" charset="0"/>
-            </a:endParaRPr>
-          </a:p>
-        </p:txBody>
-      </p:sp>
-      <p:sp>
-        <p:nvSpPr>
-          <p:cNvPr id="33" name="Rectangle: Rounded Corners 32">
-            <a:extLst>
-              <a:ext uri="{FF2B5EF4-FFF2-40B4-BE49-F238E27FC236}">
-                <a16:creationId xmlns:a16="http://schemas.microsoft.com/office/drawing/2014/main" id="{F782143D-917A-4630-A7FB-072612AFAFCB}"/>
-              </a:ext>
-            </a:extLst>
-          </p:cNvPr>
-          <p:cNvSpPr/>
-          <p:nvPr/>
-        </p:nvSpPr>
-        <p:spPr>
-          <a:xfrm>
-            <a:off x="3242037" y="2886769"/>
-            <a:ext cx="994383" cy="412615"/>
-          </a:xfrm>
-          <a:prstGeom prst="roundRect">
-            <a:avLst/>
-          </a:prstGeom>
-          <a:gradFill flip="none" rotWithShape="1">
-            <a:gsLst>
-              <a:gs pos="84000">
-                <a:srgbClr val="75D4FF"/>
-              </a:gs>
-              <a:gs pos="68000">
-                <a:srgbClr val="00B0F0"/>
-              </a:gs>
-              <a:gs pos="100000">
-                <a:schemeClr val="bg1">
-                  <a:lumMod val="95000"/>
-                </a:schemeClr>
-              </a:gs>
-            </a:gsLst>
-            <a:lin ang="18900000" scaled="1"/>
-            <a:tileRect/>
-          </a:gradFill>
-          <a:ln>
-            <a:noFill/>
-          </a:ln>
-          <a:effectLst>
-            <a:outerShdw blurRad="50800" dist="38100" dir="8100000" algn="tr" rotWithShape="0">
-              <a:prstClr val="black">
-                <a:alpha val="40000"/>
-              </a:prstClr>
-            </a:outerShdw>
-          </a:effectLst>
-        </p:spPr>
-        <p:style>
-          <a:lnRef idx="2">
-            <a:schemeClr val="accent1">
-              <a:shade val="50000"/>
-            </a:schemeClr>
-          </a:lnRef>
-          <a:fillRef idx="1">
-            <a:schemeClr val="accent1"/>
-          </a:fillRef>
-          <a:effectRef idx="0">
-            <a:schemeClr val="accent1"/>
-          </a:effectRef>
-          <a:fontRef idx="minor">
-            <a:schemeClr val="lt1"/>
-          </a:fontRef>
-        </p:style>
-        <p:txBody>
-          <a:bodyPr rtlCol="0" anchor="ctr"/>
-          <a:lstStyle/>
-          <a:p>
-            <a:pPr algn="ctr"/>
-            <a:r>
-              <a:rPr lang="en-US" sz="1408" dirty="0">
-                <a:solidFill>
-                  <a:schemeClr val="tx1"/>
-                </a:solidFill>
-                <a:latin typeface="Arial" panose="020B0604020202020204" pitchFamily="34" charset="0"/>
-                <a:cs typeface="Arial" panose="020B0604020202020204" pitchFamily="34" charset="0"/>
-              </a:rPr>
-              <a:t>846</a:t>
-            </a:r>
-            <a:endParaRPr lang="de-DE" sz="1408" dirty="0">
-              <a:solidFill>
-                <a:schemeClr val="tx1"/>
-              </a:solidFill>
-              <a:latin typeface="Arial" panose="020B0604020202020204" pitchFamily="34" charset="0"/>
-              <a:cs typeface="Arial" panose="020B0604020202020204" pitchFamily="34" charset="0"/>
-            </a:endParaRPr>
-          </a:p>
-        </p:txBody>
-      </p:sp>
-      <p:cxnSp>
-        <p:nvCxnSpPr>
-          <p:cNvPr id="34" name="Straight Arrow Connector 33">
-            <a:extLst>
-              <a:ext uri="{FF2B5EF4-FFF2-40B4-BE49-F238E27FC236}">
-                <a16:creationId xmlns:a16="http://schemas.microsoft.com/office/drawing/2014/main" id="{588FEEB8-535C-4F9D-BE06-D60DEC78B11A}"/>
-              </a:ext>
-            </a:extLst>
-          </p:cNvPr>
-          <p:cNvCxnSpPr>
-            <a:cxnSpLocks/>
-            <a:stCxn id="32" idx="2"/>
-            <a:endCxn id="33" idx="0"/>
-          </p:cNvCxnSpPr>
-          <p:nvPr/>
-        </p:nvCxnSpPr>
-        <p:spPr>
-          <a:xfrm>
-            <a:off x="3739225" y="2219602"/>
-            <a:ext cx="0" cy="667167"/>
-          </a:xfrm>
-          <a:prstGeom prst="straightConnector1">
-            <a:avLst/>
-          </a:prstGeom>
-          <a:ln>
-            <a:solidFill>
-              <a:schemeClr val="bg1">
-                <a:lumMod val="65000"/>
-              </a:schemeClr>
-            </a:solidFill>
-            <a:tailEnd type="triangle"/>
-          </a:ln>
-        </p:spPr>
-        <p:style>
-          <a:lnRef idx="1">
-            <a:schemeClr val="accent1"/>
-          </a:lnRef>
-          <a:fillRef idx="0">
-            <a:schemeClr val="accent1"/>
-          </a:fillRef>
-          <a:effectRef idx="0">
-            <a:schemeClr val="accent1"/>
-          </a:effectRef>
-          <a:fontRef idx="minor">
-            <a:schemeClr val="tx1"/>
-          </a:fontRef>
-        </p:style>
-      </p:cxnSp>
-      <p:sp>
-        <p:nvSpPr>
-          <p:cNvPr id="35" name="Rectangle 34">
-            <a:extLst>
-              <a:ext uri="{FF2B5EF4-FFF2-40B4-BE49-F238E27FC236}">
-                <a16:creationId xmlns:a16="http://schemas.microsoft.com/office/drawing/2014/main" id="{F8014AD8-AB9C-478D-A1B4-21E726B7E060}"/>
-              </a:ext>
-            </a:extLst>
-          </p:cNvPr>
-          <p:cNvSpPr/>
-          <p:nvPr/>
-        </p:nvSpPr>
-        <p:spPr>
-          <a:xfrm>
-            <a:off x="4227466" y="2939591"/>
-            <a:ext cx="1828125" cy="290977"/>
-          </a:xfrm>
-          <a:prstGeom prst="rect">
-            <a:avLst/>
-          </a:prstGeom>
-        </p:spPr>
-        <p:txBody>
-          <a:bodyPr wrap="square">
-            <a:spAutoFit/>
-          </a:bodyPr>
-          <a:lstStyle/>
-          <a:p>
-            <a:r>
-              <a:rPr lang="en-US" sz="1291" dirty="0">
-                <a:latin typeface="Arial" panose="020B0604020202020204" pitchFamily="34" charset="0"/>
-                <a:cs typeface="Arial" panose="020B0604020202020204" pitchFamily="34" charset="0"/>
-              </a:rPr>
-              <a:t>Estimated Citations</a:t>
-            </a:r>
-            <a:endParaRPr lang="de-DE" sz="1291" dirty="0">
-              <a:latin typeface="Arial" panose="020B0604020202020204" pitchFamily="34" charset="0"/>
-              <a:cs typeface="Arial" panose="020B0604020202020204" pitchFamily="34" charset="0"/>
-            </a:endParaRPr>
-          </a:p>
-        </p:txBody>
-      </p:sp>
-      <p:sp>
-        <p:nvSpPr>
-          <p:cNvPr id="36" name="Rectangle: Rounded Corners 35">
-            <a:extLst>
-              <a:ext uri="{FF2B5EF4-FFF2-40B4-BE49-F238E27FC236}">
-                <a16:creationId xmlns:a16="http://schemas.microsoft.com/office/drawing/2014/main" id="{A66615DB-D6CA-4E80-B064-CD8973E779A9}"/>
-              </a:ext>
-            </a:extLst>
-          </p:cNvPr>
-          <p:cNvSpPr/>
-          <p:nvPr/>
-        </p:nvSpPr>
-        <p:spPr>
-          <a:xfrm>
-            <a:off x="3242037" y="710674"/>
-            <a:ext cx="994383" cy="412615"/>
-          </a:xfrm>
-          <a:prstGeom prst="roundRect">
-            <a:avLst/>
-          </a:prstGeom>
-          <a:gradFill flip="none" rotWithShape="1">
-            <a:gsLst>
-              <a:gs pos="84000">
-                <a:srgbClr val="75D4FF"/>
-              </a:gs>
-              <a:gs pos="68000">
-                <a:srgbClr val="00B0F0"/>
-              </a:gs>
-              <a:gs pos="100000">
-                <a:schemeClr val="bg1">
-                  <a:lumMod val="95000"/>
-                </a:schemeClr>
-              </a:gs>
-            </a:gsLst>
-            <a:lin ang="18900000" scaled="1"/>
-            <a:tileRect/>
-          </a:gradFill>
-          <a:ln>
-            <a:noFill/>
-          </a:ln>
-          <a:effectLst>
-            <a:outerShdw blurRad="50800" dist="38100" dir="8100000" algn="tr" rotWithShape="0">
-              <a:prstClr val="black">
-                <a:alpha val="40000"/>
-              </a:prstClr>
-            </a:outerShdw>
-          </a:effectLst>
-        </p:spPr>
-        <p:style>
-          <a:lnRef idx="2">
-            <a:schemeClr val="accent1">
-              <a:shade val="50000"/>
-            </a:schemeClr>
-          </a:lnRef>
-          <a:fillRef idx="1">
-            <a:schemeClr val="accent1"/>
-          </a:fillRef>
-          <a:effectRef idx="0">
-            <a:schemeClr val="accent1"/>
-          </a:effectRef>
-          <a:fontRef idx="minor">
-            <a:schemeClr val="lt1"/>
-          </a:fontRef>
-        </p:style>
-        <p:txBody>
-          <a:bodyPr rtlCol="0" anchor="ctr"/>
-          <a:lstStyle/>
-          <a:p>
-            <a:pPr algn="ctr"/>
-            <a:r>
-              <a:rPr lang="en-US" sz="1408" dirty="0">
-                <a:solidFill>
-                  <a:schemeClr val="tx1"/>
-                </a:solidFill>
-                <a:latin typeface="Arial" panose="020B0604020202020204" pitchFamily="34" charset="0"/>
-                <a:cs typeface="Arial" panose="020B0604020202020204" pitchFamily="34" charset="0"/>
-              </a:rPr>
-              <a:t>35</a:t>
-            </a:r>
-            <a:endParaRPr lang="de-DE" sz="1408" dirty="0">
-              <a:solidFill>
-                <a:schemeClr val="tx1"/>
-              </a:solidFill>
-              <a:latin typeface="Arial" panose="020B0604020202020204" pitchFamily="34" charset="0"/>
-              <a:cs typeface="Arial" panose="020B0604020202020204" pitchFamily="34" charset="0"/>
-            </a:endParaRPr>
-          </a:p>
-        </p:txBody>
-      </p:sp>
-      <p:cxnSp>
-        <p:nvCxnSpPr>
-          <p:cNvPr id="37" name="Straight Arrow Connector 36">
-            <a:extLst>
-              <a:ext uri="{FF2B5EF4-FFF2-40B4-BE49-F238E27FC236}">
-                <a16:creationId xmlns:a16="http://schemas.microsoft.com/office/drawing/2014/main" id="{9CB45425-9B7D-49B1-B7E6-6CE84CD5DD4F}"/>
-              </a:ext>
-            </a:extLst>
-          </p:cNvPr>
-          <p:cNvCxnSpPr>
-            <a:cxnSpLocks/>
-            <a:stCxn id="36" idx="2"/>
-            <a:endCxn id="32" idx="0"/>
-          </p:cNvCxnSpPr>
-          <p:nvPr/>
-        </p:nvCxnSpPr>
-        <p:spPr>
-          <a:xfrm>
-            <a:off x="3739225" y="1123285"/>
-            <a:ext cx="0" cy="683700"/>
-          </a:xfrm>
-          <a:prstGeom prst="straightConnector1">
-            <a:avLst/>
-          </a:prstGeom>
-          <a:ln>
-            <a:solidFill>
-              <a:schemeClr val="bg1">
-                <a:lumMod val="65000"/>
-              </a:schemeClr>
-            </a:solidFill>
-            <a:tailEnd type="triangle"/>
-          </a:ln>
-        </p:spPr>
-        <p:style>
-          <a:lnRef idx="1">
-            <a:schemeClr val="accent1"/>
-          </a:lnRef>
-          <a:fillRef idx="0">
-            <a:schemeClr val="accent1"/>
-          </a:fillRef>
-          <a:effectRef idx="0">
-            <a:schemeClr val="accent1"/>
-          </a:effectRef>
-          <a:fontRef idx="minor">
-            <a:schemeClr val="tx1"/>
-          </a:fontRef>
-        </p:style>
-      </p:cxnSp>
-      <p:sp>
-        <p:nvSpPr>
-          <p:cNvPr id="38" name="Rectangle 37">
-            <a:extLst>
-              <a:ext uri="{FF2B5EF4-FFF2-40B4-BE49-F238E27FC236}">
-                <a16:creationId xmlns:a16="http://schemas.microsoft.com/office/drawing/2014/main" id="{793B5009-2567-4219-828C-A2FC4468E2F5}"/>
-              </a:ext>
-            </a:extLst>
-          </p:cNvPr>
-          <p:cNvSpPr/>
-          <p:nvPr/>
-        </p:nvSpPr>
-        <p:spPr>
-          <a:xfrm>
-            <a:off x="4231944" y="754467"/>
-            <a:ext cx="1610547" cy="290977"/>
-          </a:xfrm>
-          <a:prstGeom prst="rect">
-            <a:avLst/>
-          </a:prstGeom>
-        </p:spPr>
-        <p:txBody>
-          <a:bodyPr wrap="square">
-            <a:spAutoFit/>
-          </a:bodyPr>
-          <a:lstStyle/>
-          <a:p>
-            <a:r>
-              <a:rPr lang="en-US" sz="1291" dirty="0">
-                <a:latin typeface="Arial" panose="020B0604020202020204" pitchFamily="34" charset="0"/>
-                <a:cs typeface="Arial" panose="020B0604020202020204" pitchFamily="34" charset="0"/>
-              </a:rPr>
-              <a:t>Charité Datasets</a:t>
-            </a:r>
-            <a:endParaRPr lang="de-DE" sz="1291" dirty="0">
-              <a:latin typeface="Arial" panose="020B0604020202020204" pitchFamily="34" charset="0"/>
-              <a:cs typeface="Arial" panose="020B0604020202020204" pitchFamily="34" charset="0"/>
-            </a:endParaRPr>
-          </a:p>
-        </p:txBody>
-      </p:sp>
-      <p:sp>
-        <p:nvSpPr>
-          <p:cNvPr id="39" name="Rectangle: Rounded Corners 38">
-            <a:extLst>
-              <a:ext uri="{FF2B5EF4-FFF2-40B4-BE49-F238E27FC236}">
-                <a16:creationId xmlns:a16="http://schemas.microsoft.com/office/drawing/2014/main" id="{D4DE513D-2FB1-49B7-A2CE-E030FD9CE2A4}"/>
-              </a:ext>
-            </a:extLst>
-          </p:cNvPr>
-          <p:cNvSpPr/>
-          <p:nvPr/>
-        </p:nvSpPr>
-        <p:spPr>
-          <a:xfrm>
-            <a:off x="3237560" y="-388436"/>
-            <a:ext cx="994383" cy="412615"/>
-          </a:xfrm>
-          <a:prstGeom prst="roundRect">
-            <a:avLst/>
-          </a:prstGeom>
-          <a:gradFill flip="none" rotWithShape="1">
-            <a:gsLst>
-              <a:gs pos="84000">
-                <a:srgbClr val="75D4FF"/>
-              </a:gs>
-              <a:gs pos="68000">
-                <a:srgbClr val="00B0F0"/>
-              </a:gs>
-              <a:gs pos="100000">
-                <a:schemeClr val="bg1">
-                  <a:lumMod val="95000"/>
-                </a:schemeClr>
-              </a:gs>
-            </a:gsLst>
-            <a:lin ang="18900000" scaled="1"/>
-            <a:tileRect/>
-          </a:gradFill>
-          <a:ln>
-            <a:noFill/>
-          </a:ln>
-          <a:effectLst>
-            <a:outerShdw blurRad="50800" dist="38100" dir="8100000" algn="tr" rotWithShape="0">
-              <a:prstClr val="black">
-                <a:alpha val="40000"/>
-              </a:prstClr>
-            </a:outerShdw>
-          </a:effectLst>
-        </p:spPr>
-        <p:style>
-          <a:lnRef idx="2">
-            <a:schemeClr val="accent1">
-              <a:shade val="50000"/>
-            </a:schemeClr>
-          </a:lnRef>
-          <a:fillRef idx="1">
-            <a:schemeClr val="accent1"/>
-          </a:fillRef>
-          <a:effectRef idx="0">
-            <a:schemeClr val="accent1"/>
-          </a:effectRef>
-          <a:fontRef idx="minor">
-            <a:schemeClr val="lt1"/>
-          </a:fontRef>
-        </p:style>
-        <p:txBody>
-          <a:bodyPr rtlCol="0" anchor="ctr"/>
-          <a:lstStyle/>
-          <a:p>
-            <a:pPr algn="ctr"/>
-            <a:r>
-              <a:rPr lang="en-US" sz="1408" dirty="0">
-                <a:solidFill>
-                  <a:schemeClr val="tx1"/>
-                </a:solidFill>
-                <a:latin typeface="Arial" panose="020B0604020202020204" pitchFamily="34" charset="0"/>
-                <a:cs typeface="Arial" panose="020B0604020202020204" pitchFamily="34" charset="0"/>
-              </a:rPr>
-              <a:t>21</a:t>
-            </a:r>
-            <a:endParaRPr lang="de-DE" sz="1408" dirty="0">
-              <a:solidFill>
-                <a:schemeClr val="tx1"/>
-              </a:solidFill>
-              <a:latin typeface="Arial" panose="020B0604020202020204" pitchFamily="34" charset="0"/>
-              <a:cs typeface="Arial" panose="020B0604020202020204" pitchFamily="34" charset="0"/>
-            </a:endParaRPr>
-          </a:p>
-        </p:txBody>
-      </p:sp>
-      <p:cxnSp>
-        <p:nvCxnSpPr>
-          <p:cNvPr id="40" name="Straight Arrow Connector 39">
-            <a:extLst>
-              <a:ext uri="{FF2B5EF4-FFF2-40B4-BE49-F238E27FC236}">
-                <a16:creationId xmlns:a16="http://schemas.microsoft.com/office/drawing/2014/main" id="{02B4690F-D349-475B-81BF-F2E80E19C269}"/>
-              </a:ext>
-            </a:extLst>
-          </p:cNvPr>
-          <p:cNvCxnSpPr>
-            <a:cxnSpLocks/>
-            <a:stCxn id="39" idx="2"/>
-            <a:endCxn id="36" idx="0"/>
-          </p:cNvCxnSpPr>
-          <p:nvPr/>
-        </p:nvCxnSpPr>
-        <p:spPr>
-          <a:xfrm>
-            <a:off x="3734752" y="24178"/>
-            <a:ext cx="4479" cy="686493"/>
-          </a:xfrm>
-          <a:prstGeom prst="straightConnector1">
-            <a:avLst/>
-          </a:prstGeom>
-          <a:ln>
-            <a:solidFill>
-              <a:schemeClr val="bg1">
-                <a:lumMod val="65000"/>
-              </a:schemeClr>
-            </a:solidFill>
-            <a:tailEnd type="triangle"/>
-          </a:ln>
-        </p:spPr>
-        <p:style>
-          <a:lnRef idx="1">
-            <a:schemeClr val="accent1"/>
-          </a:lnRef>
-          <a:fillRef idx="0">
-            <a:schemeClr val="accent1"/>
-          </a:fillRef>
-          <a:effectRef idx="0">
-            <a:schemeClr val="accent1"/>
-          </a:effectRef>
-          <a:fontRef idx="minor">
-            <a:schemeClr val="tx1"/>
-          </a:fontRef>
-        </p:style>
-      </p:cxnSp>
-      <p:sp>
-        <p:nvSpPr>
-          <p:cNvPr id="41" name="Rectangle 40">
-            <a:extLst>
-              <a:ext uri="{FF2B5EF4-FFF2-40B4-BE49-F238E27FC236}">
-                <a16:creationId xmlns:a16="http://schemas.microsoft.com/office/drawing/2014/main" id="{DFB321C3-1C3C-4DCB-87EF-3C35A20F30A0}"/>
-              </a:ext>
-            </a:extLst>
-          </p:cNvPr>
-          <p:cNvSpPr/>
-          <p:nvPr/>
-        </p:nvSpPr>
-        <p:spPr>
-          <a:xfrm>
-            <a:off x="4227464" y="-344642"/>
-            <a:ext cx="1828125" cy="290977"/>
-          </a:xfrm>
-          <a:prstGeom prst="rect">
-            <a:avLst/>
-          </a:prstGeom>
-        </p:spPr>
-        <p:txBody>
-          <a:bodyPr wrap="square">
-            <a:spAutoFit/>
-          </a:bodyPr>
-          <a:lstStyle/>
-          <a:p>
-            <a:r>
-              <a:rPr lang="en-US" sz="1291" dirty="0">
-                <a:latin typeface="Arial" panose="020B0604020202020204" pitchFamily="34" charset="0"/>
-                <a:cs typeface="Arial" panose="020B0604020202020204" pitchFamily="34" charset="0"/>
-              </a:rPr>
-              <a:t>Charité Data Articles</a:t>
-            </a:r>
-            <a:endParaRPr lang="de-DE" sz="1291" dirty="0">
-              <a:latin typeface="Arial" panose="020B0604020202020204" pitchFamily="34" charset="0"/>
-              <a:cs typeface="Arial" panose="020B0604020202020204" pitchFamily="34" charset="0"/>
-            </a:endParaRPr>
-          </a:p>
-        </p:txBody>
-      </p:sp>
-    </p:spTree>
-    <p:extLst>
-      <p:ext uri="{BB962C8B-B14F-4D97-AF65-F5344CB8AC3E}">
-        <p14:creationId xmlns:p14="http://schemas.microsoft.com/office/powerpoint/2010/main" val="225445080"/>
       </p:ext>
     </p:extLst>
   </p:cSld>

</xml_diff>

<commit_message>
First round of corrections in text according to EB's comments; Rendered html and pdf
</commit_message>
<xml_diff>
--- a/plots_files/plots_png/pptx/plots_png.pptx
+++ b/plots_files/plots_png/pptx/plots_png.pptx
@@ -1,6 +1,6 @@
 
 <file path=ppt/presentation.xml><?xml version="1.0" encoding="utf-8"?>
-<p:presentation xmlns:a="http://schemas.openxmlformats.org/drawingml/2006/main" xmlns:r="http://schemas.openxmlformats.org/officeDocument/2006/relationships" xmlns:p="http://schemas.openxmlformats.org/presentationml/2006/main" saveSubsetFonts="1">
+<p:presentation xmlns:a="http://schemas.openxmlformats.org/drawingml/2006/main" xmlns:r="http://schemas.openxmlformats.org/officeDocument/2006/relationships" xmlns:p="http://schemas.openxmlformats.org/presentationml/2006/main" saveSubsetFonts="1" autoCompressPictures="0">
   <p:sldMasterIdLst>
     <p:sldMasterId id="2147483684" r:id="rId1"/>
   </p:sldMasterIdLst>
@@ -254,7 +254,7 @@
           <a:p>
             <a:fld id="{83D14EEA-DE26-4810-8E05-A65F0010FADE}" type="datetimeFigureOut">
               <a:rPr lang="de-DE" smtClean="0"/>
-              <a:t>25.03.2026</a:t>
+              <a:t>02.09.2026</a:t>
             </a:fld>
             <a:endParaRPr lang="de-DE"/>
           </a:p>
@@ -424,7 +424,7 @@
           <a:p>
             <a:fld id="{83D14EEA-DE26-4810-8E05-A65F0010FADE}" type="datetimeFigureOut">
               <a:rPr lang="de-DE" smtClean="0"/>
-              <a:t>25.03.2026</a:t>
+              <a:t>02.09.2026</a:t>
             </a:fld>
             <a:endParaRPr lang="de-DE"/>
           </a:p>
@@ -604,7 +604,7 @@
           <a:p>
             <a:fld id="{83D14EEA-DE26-4810-8E05-A65F0010FADE}" type="datetimeFigureOut">
               <a:rPr lang="de-DE" smtClean="0"/>
-              <a:t>25.03.2026</a:t>
+              <a:t>02.09.2026</a:t>
             </a:fld>
             <a:endParaRPr lang="de-DE"/>
           </a:p>
@@ -774,7 +774,7 @@
           <a:p>
             <a:fld id="{83D14EEA-DE26-4810-8E05-A65F0010FADE}" type="datetimeFigureOut">
               <a:rPr lang="de-DE" smtClean="0"/>
-              <a:t>25.03.2026</a:t>
+              <a:t>02.09.2026</a:t>
             </a:fld>
             <a:endParaRPr lang="de-DE"/>
           </a:p>
@@ -1018,7 +1018,7 @@
           <a:p>
             <a:fld id="{83D14EEA-DE26-4810-8E05-A65F0010FADE}" type="datetimeFigureOut">
               <a:rPr lang="de-DE" smtClean="0"/>
-              <a:t>25.03.2026</a:t>
+              <a:t>02.09.2026</a:t>
             </a:fld>
             <a:endParaRPr lang="de-DE"/>
           </a:p>
@@ -1250,7 +1250,7 @@
           <a:p>
             <a:fld id="{83D14EEA-DE26-4810-8E05-A65F0010FADE}" type="datetimeFigureOut">
               <a:rPr lang="de-DE" smtClean="0"/>
-              <a:t>25.03.2026</a:t>
+              <a:t>02.09.2026</a:t>
             </a:fld>
             <a:endParaRPr lang="de-DE"/>
           </a:p>
@@ -1617,7 +1617,7 @@
           <a:p>
             <a:fld id="{83D14EEA-DE26-4810-8E05-A65F0010FADE}" type="datetimeFigureOut">
               <a:rPr lang="de-DE" smtClean="0"/>
-              <a:t>25.03.2026</a:t>
+              <a:t>02.09.2026</a:t>
             </a:fld>
             <a:endParaRPr lang="de-DE"/>
           </a:p>
@@ -1735,7 +1735,7 @@
           <a:p>
             <a:fld id="{83D14EEA-DE26-4810-8E05-A65F0010FADE}" type="datetimeFigureOut">
               <a:rPr lang="de-DE" smtClean="0"/>
-              <a:t>25.03.2026</a:t>
+              <a:t>02.09.2026</a:t>
             </a:fld>
             <a:endParaRPr lang="de-DE"/>
           </a:p>
@@ -1830,7 +1830,7 @@
           <a:p>
             <a:fld id="{83D14EEA-DE26-4810-8E05-A65F0010FADE}" type="datetimeFigureOut">
               <a:rPr lang="de-DE" smtClean="0"/>
-              <a:t>25.03.2026</a:t>
+              <a:t>02.09.2026</a:t>
             </a:fld>
             <a:endParaRPr lang="de-DE"/>
           </a:p>
@@ -2107,7 +2107,7 @@
           <a:p>
             <a:fld id="{83D14EEA-DE26-4810-8E05-A65F0010FADE}" type="datetimeFigureOut">
               <a:rPr lang="de-DE" smtClean="0"/>
-              <a:t>25.03.2026</a:t>
+              <a:t>02.09.2026</a:t>
             </a:fld>
             <a:endParaRPr lang="de-DE"/>
           </a:p>
@@ -2364,7 +2364,7 @@
           <a:p>
             <a:fld id="{83D14EEA-DE26-4810-8E05-A65F0010FADE}" type="datetimeFigureOut">
               <a:rPr lang="de-DE" smtClean="0"/>
-              <a:t>25.03.2026</a:t>
+              <a:t>02.09.2026</a:t>
             </a:fld>
             <a:endParaRPr lang="de-DE"/>
           </a:p>
@@ -2577,7 +2577,7 @@
           <a:p>
             <a:fld id="{83D14EEA-DE26-4810-8E05-A65F0010FADE}" type="datetimeFigureOut">
               <a:rPr lang="de-DE" smtClean="0"/>
-              <a:t>25.03.2026</a:t>
+              <a:t>02.09.2026</a:t>
             </a:fld>
             <a:endParaRPr lang="de-DE"/>
           </a:p>
@@ -3511,7 +3511,7 @@
                   <a:latin typeface="Arial" panose="020B0604020202020204" pitchFamily="34" charset="0"/>
                   <a:cs typeface="Arial" panose="020B0604020202020204" pitchFamily="34" charset="0"/>
                 </a:rPr>
-                <a:t>of Datasets</a:t>
+                <a:t>to Datasets</a:t>
               </a:r>
             </a:p>
           </p:txBody>
@@ -3979,7 +3979,7 @@
                   <a:latin typeface="Arial" panose="020B0604020202020204" pitchFamily="34" charset="0"/>
                   <a:cs typeface="Arial" panose="020B0604020202020204" pitchFamily="34" charset="0"/>
                 </a:rPr>
-                <a:t>of Datasets</a:t>
+                <a:t>to Datasets</a:t>
               </a:r>
               <a:endParaRPr lang="de-DE" sz="1291" dirty="0">
                 <a:latin typeface="Arial" panose="020B0604020202020204" pitchFamily="34" charset="0"/>
@@ -4073,7 +4073,7 @@
                   <a:latin typeface="Arial" panose="020B0604020202020204" pitchFamily="34" charset="0"/>
                   <a:cs typeface="Arial" panose="020B0604020202020204" pitchFamily="34" charset="0"/>
                 </a:rPr>
-                <a:t>References of Datasets</a:t>
+                <a:t>References to Datasets</a:t>
               </a:r>
             </a:p>
             <a:p>

</xml_diff>